<commit_message>
fix: resolve out-of-box test execution, script imports, and active aero parameter consistency
</commit_message>
<xml_diff>
--- a/results/presentation/F1_Wing_Angle_Performance_Presentation.pptx
+++ b/results/presentation/F1_Wing_Angle_Performance_Presentation.pptx
@@ -5842,7 +5842,7 @@
               </a:defRPr>
             </a:pPr>
             <a:r>
-              <a:t>•  Actuator-Limited Active Aero: Real-world 25°/s slew rate limit prevents instantaneous transitions; achieved lap times: Balanced 59.353 s, Low-DF 68.599 s, High-DF 64.615 s.</a:t>
+              <a:t>•  Actuator-Limited Active Aero: Real-world 90°/s slew rate limit prevents instantaneous transitions; achieved lap times: Balanced 59.353 s, Low-DF 68.599 s, High-DF 64.615 s.</a:t>
             </a:r>
           </a:p>
         </p:txBody>
@@ -5904,7 +5904,7 @@
                         </a:defRPr>
                       </a:pPr>
                       <a:r>
-                        <a:t>25.0 °/s</a:t>
+                        <a:t>90.0 °/s</a:t>
                       </a:r>
                     </a:p>
                   </a:txBody>
@@ -7339,7 +7339,7 @@
               </a:defRPr>
             </a:pPr>
             <a:r>
-              <a:t>•  Active Aerodynamics Advantage: Actuator-limited active aero captures the majority of ideal drag reduction while maintaining cornering safety.</a:t>
+              <a:t>•  Active Aero Control Lesson: Ideal active aero improves lap time by up to -0.54 s, but finite 90°/s slew rates and transition delays incur penalties (+0.09s to +0.54s) under naive threshold switching.</a:t>
             </a:r>
           </a:p>
           <a:p>
@@ -7620,7 +7620,7 @@
                         </a:defRPr>
                       </a:pPr>
                       <a:r>
-                        <a:t>Active Aero Gain</a:t>
+                        <a:t>Active Aero Trade-off</a:t>
                       </a:r>
                     </a:p>
                   </a:txBody>
@@ -7640,7 +7640,7 @@
                         </a:defRPr>
                       </a:pPr>
                       <a:r>
-                        <a:t>Significant on high-speed straights</a:t>
+                        <a:t>Ideal -0.54s / Limited +0.09s to +0.54s</a:t>
                       </a:r>
                     </a:p>
                   </a:txBody>
@@ -9138,7 +9138,7 @@
                         </a:defRPr>
                       </a:pPr>
                       <a:r>
-                        <a:t>Fixed, Open-Wing, Active (25°/s)</a:t>
+                        <a:t>Fixed, Open-Wing, Active (90°/s)</a:t>
                       </a:r>
                     </a:p>
                   </a:txBody>

</xml_diff>